<commit_message>
cambios en el ppt
</commit_message>
<xml_diff>
--- a/Presentacion_Final_Churn.pptx
+++ b/Presentacion_Final_Churn.pptx
@@ -2361,7 +2361,7 @@
         </p:blipFill>
         <p:spPr>
           <a:xfrm>
-            <a:off x="502920" y="1170432"/>
+            <a:off x="1441542" y="1170432"/>
             <a:ext cx="5806440" cy="3410712"/>
           </a:xfrm>
           <a:prstGeom prst="rect">
@@ -2369,121 +2369,6 @@
           </a:prstGeom>
         </p:spPr>
       </p:pic>
-      <p:sp>
-        <p:nvSpPr>
-          <p:cNvPr id="5" name="Shape 2"/>
-          <p:cNvSpPr/>
-          <p:nvPr/>
-        </p:nvSpPr>
-        <p:spPr>
-          <a:xfrm>
-            <a:off x="6766560" y="1298448"/>
-            <a:ext cx="2057400" cy="2244095"/>
-          </a:xfrm>
-          <a:prstGeom prst="roundRect">
-            <a:avLst>
-              <a:gd name="adj" fmla="val 3556"/>
-            </a:avLst>
-          </a:prstGeom>
-          <a:solidFill>
-            <a:srgbClr val="F2F5FC"/>
-          </a:solidFill>
-          <a:ln/>
-          <a:effectLst>
-            <a:outerShdw blurRad="88900" dist="25400" dir="2700000" algn="bl" rotWithShape="0">
-              <a:srgbClr val="8A93A6">
-                <a:alpha val="22000"/>
-              </a:srgbClr>
-            </a:outerShdw>
-          </a:effectLst>
-        </p:spPr>
-        <p:txBody>
-          <a:bodyPr/>
-          <a:lstStyle/>
-          <a:p>
-            <a:endParaRPr lang="en-US"/>
-          </a:p>
-        </p:txBody>
-      </p:sp>
-      <p:sp>
-        <p:nvSpPr>
-          <p:cNvPr id="6" name="Text 3"/>
-          <p:cNvSpPr/>
-          <p:nvPr/>
-        </p:nvSpPr>
-        <p:spPr>
-          <a:xfrm>
-            <a:off x="6922008" y="1444752"/>
-            <a:ext cx="1755648" cy="2971800"/>
-          </a:xfrm>
-          <a:prstGeom prst="rect">
-            <a:avLst/>
-          </a:prstGeom>
-          <a:noFill/>
-          <a:ln/>
-        </p:spPr>
-        <p:txBody>
-          <a:bodyPr wrap="square" lIns="0" tIns="0" rIns="0" bIns="0" rtlCol="0" anchor="t"/>
-          <a:lstStyle/>
-          <a:p>
-            <a:pPr marL="0" indent="0">
-              <a:spcAft>
-                <a:spcPts val="900"/>
-              </a:spcAft>
-              <a:buNone/>
-            </a:pPr>
-            <a:r>
-              <a:rPr lang="en-US" sz="1350" b="1" dirty="0">
-                <a:solidFill>
-                  <a:srgbClr val="1E2761"/>
-                </a:solidFill>
-                <a:latin typeface="Calibri" pitchFamily="34" charset="0"/>
-                <a:ea typeface="Calibri" pitchFamily="34" charset="-122"/>
-                <a:cs typeface="Calibri" pitchFamily="34" charset="-120"/>
-              </a:rPr>
-              <a:t>Con defaults, nadie le gana a la logística</a:t>
-            </a:r>
-            <a:endParaRPr lang="en-US" sz="1350" dirty="0"/>
-          </a:p>
-          <a:p>
-            <a:pPr marL="0" indent="0">
-              <a:spcAft>
-                <a:spcPts val="900"/>
-              </a:spcAft>
-              <a:buNone/>
-            </a:pPr>
-            <a:r>
-              <a:rPr lang="en-US" sz="1250" dirty="0">
-                <a:solidFill>
-                  <a:srgbClr val="2B3147"/>
-                </a:solidFill>
-                <a:latin typeface="Calibri" pitchFamily="34" charset="0"/>
-                <a:ea typeface="Calibri" pitchFamily="34" charset="-122"/>
-                <a:cs typeface="Calibri" pitchFamily="34" charset="-120"/>
-              </a:rPr>
-              <a:t>El feature engineering ayuda a los lineales; los árboles encuentran las interacciones solos</a:t>
-            </a:r>
-            <a:endParaRPr lang="en-US" sz="1350" dirty="0"/>
-          </a:p>
-          <a:p>
-            <a:pPr marL="0" indent="0">
-              <a:buNone/>
-            </a:pPr>
-            <a:r>
-              <a:rPr lang="en-US" sz="1250" b="1" dirty="0">
-                <a:solidFill>
-                  <a:srgbClr val="F96167"/>
-                </a:solidFill>
-                <a:latin typeface="Calibri" pitchFamily="34" charset="0"/>
-                <a:ea typeface="Calibri" pitchFamily="34" charset="-122"/>
-                <a:cs typeface="Calibri" pitchFamily="34" charset="-120"/>
-              </a:rPr>
-              <a:t>Top 5 separados por &lt; 0,02 → la definición queda para el tuning</a:t>
-            </a:r>
-            <a:endParaRPr lang="en-US" sz="1350" dirty="0"/>
-          </a:p>
-        </p:txBody>
-      </p:sp>
     </p:spTree>
   </p:cSld>
   <p:clrMapOvr>
@@ -3775,8 +3660,8 @@
         </p:nvSpPr>
         <p:spPr>
           <a:xfrm>
-            <a:off x="6537960" y="1261872"/>
-            <a:ext cx="2240280" cy="2371505"/>
+            <a:off x="6537960" y="1261873"/>
+            <a:ext cx="2240280" cy="2020278"/>
           </a:xfrm>
           <a:prstGeom prst="roundRect">
             <a:avLst>
@@ -3860,26 +3745,6 @@
                 <a:cs typeface="Calibri" pitchFamily="34" charset="-120"/>
               </a:rPr>
               <a:t>F2 prioriza recall: conviene aceptar falsas alarmas antes que dejar escapar churners.</a:t>
-            </a:r>
-            <a:endParaRPr lang="en-US" sz="1400" dirty="0"/>
-          </a:p>
-          <a:p>
-            <a:pPr marL="0" indent="0">
-              <a:spcAft>
-                <a:spcPts val="700"/>
-              </a:spcAft>
-              <a:buNone/>
-            </a:pPr>
-            <a:r>
-              <a:rPr lang="en-US" sz="1300" b="1" dirty="0">
-                <a:solidFill>
-                  <a:srgbClr val="F96167"/>
-                </a:solidFill>
-                <a:latin typeface="Calibri" pitchFamily="34" charset="0"/>
-                <a:ea typeface="Calibri" pitchFamily="34" charset="-122"/>
-                <a:cs typeface="Calibri" pitchFamily="34" charset="-120"/>
-              </a:rPr>
-              <a:t>Implica accionar sobre ~52% de la cartera</a:t>
             </a:r>
             <a:endParaRPr lang="en-US" sz="1400" dirty="0"/>
           </a:p>
@@ -4021,7 +3886,7 @@
         </p:blipFill>
         <p:spPr>
           <a:xfrm>
-            <a:off x="1271682" y="1078992"/>
+            <a:off x="1398850" y="1078992"/>
             <a:ext cx="5686235" cy="3652975"/>
           </a:xfrm>
           <a:prstGeom prst="rect">
@@ -4165,7 +4030,7 @@
         <p:spPr>
           <a:xfrm>
             <a:off x="6446520" y="1261872"/>
-            <a:ext cx="2331720" cy="3019458"/>
+            <a:ext cx="2331720" cy="2353339"/>
           </a:xfrm>
           <a:prstGeom prst="roundRect">
             <a:avLst>
@@ -4271,25 +4136,40 @@
                 <a:ea typeface="Calibri" pitchFamily="34" charset="-122"/>
                 <a:cs typeface="Calibri" pitchFamily="34" charset="-120"/>
               </a:rPr>
-              <a:t>Contrato de 2 años y tener soporte/seguridad protegen</a:t>
-            </a:r>
-            <a:endParaRPr lang="en-US" sz="1250" dirty="0"/>
-          </a:p>
-          <a:p>
-            <a:pPr marL="342900" indent="-342900">
-              <a:buSzPct val="100000"/>
-              <a:buChar char="•"/>
-            </a:pPr>
-            <a:r>
-              <a:rPr lang="en-US" sz="1250" b="1" dirty="0">
-                <a:solidFill>
-                  <a:srgbClr val="F96167"/>
-                </a:solidFill>
-                <a:latin typeface="Calibri" pitchFamily="34" charset="0"/>
-                <a:ea typeface="Calibri" pitchFamily="34" charset="-122"/>
-                <a:cs typeface="Calibri" pitchFamily="34" charset="-120"/>
-              </a:rPr>
-              <a:t>Coherencia EDA ↔ modelo = confianza para accionar</a:t>
+              <a:t>Contrato de 2 años y tener soporte/</a:t>
+            </a:r>
+            <a:r>
+              <a:rPr lang="en-US" sz="1250" dirty="0" err="1">
+                <a:solidFill>
+                  <a:srgbClr val="2B3147"/>
+                </a:solidFill>
+                <a:latin typeface="Calibri" pitchFamily="34" charset="0"/>
+                <a:ea typeface="Calibri" pitchFamily="34" charset="-122"/>
+                <a:cs typeface="Calibri" pitchFamily="34" charset="-120"/>
+              </a:rPr>
+              <a:t>seguridad</a:t>
+            </a:r>
+            <a:r>
+              <a:rPr lang="en-US" sz="1250" dirty="0">
+                <a:solidFill>
+                  <a:srgbClr val="2B3147"/>
+                </a:solidFill>
+                <a:latin typeface="Calibri" pitchFamily="34" charset="0"/>
+                <a:ea typeface="Calibri" pitchFamily="34" charset="-122"/>
+                <a:cs typeface="Calibri" pitchFamily="34" charset="-120"/>
+              </a:rPr>
+              <a:t> </a:t>
+            </a:r>
+            <a:r>
+              <a:rPr lang="en-US" sz="1250" dirty="0" err="1">
+                <a:solidFill>
+                  <a:srgbClr val="2B3147"/>
+                </a:solidFill>
+                <a:latin typeface="Calibri" pitchFamily="34" charset="0"/>
+                <a:ea typeface="Calibri" pitchFamily="34" charset="-122"/>
+                <a:cs typeface="Calibri" pitchFamily="34" charset="-120"/>
+              </a:rPr>
+              <a:t>protegen</a:t>
             </a:r>
             <a:endParaRPr lang="en-US" sz="1250" dirty="0"/>
           </a:p>
@@ -4552,7 +4432,29 @@
                 <a:ea typeface="Calibri" pitchFamily="34" charset="-122"/>
                 <a:cs typeface="Calibri" pitchFamily="34" charset="-120"/>
               </a:rPr>
-              <a:t>Probamos 2 rondas de feature engineering: no aportan — la información nueva tiene que venir de afuera</a:t>
+              <a:t>Probamos 2 rondas de feature engineering: no </a:t>
+            </a:r>
+            <a:r>
+              <a:rPr lang="en-US" sz="1350" dirty="0" err="1">
+                <a:solidFill>
+                  <a:srgbClr val="2B3147"/>
+                </a:solidFill>
+                <a:latin typeface="Calibri" pitchFamily="34" charset="0"/>
+                <a:ea typeface="Calibri" pitchFamily="34" charset="-122"/>
+                <a:cs typeface="Calibri" pitchFamily="34" charset="-120"/>
+              </a:rPr>
+              <a:t>aportan</a:t>
+            </a:r>
+            <a:r>
+              <a:rPr lang="en-US" sz="1350" dirty="0">
+                <a:solidFill>
+                  <a:srgbClr val="2B3147"/>
+                </a:solidFill>
+                <a:latin typeface="Calibri" pitchFamily="34" charset="0"/>
+                <a:ea typeface="Calibri" pitchFamily="34" charset="-122"/>
+                <a:cs typeface="Calibri" pitchFamily="34" charset="-120"/>
+              </a:rPr>
+              <a:t>, la información nueva tiene que venir de afuera</a:t>
             </a:r>
             <a:endParaRPr lang="en-US" sz="1350" dirty="0"/>
           </a:p>
@@ -4670,7 +4572,18 @@
                 <a:ea typeface="Calibri" pitchFamily="34" charset="-122"/>
                 <a:cs typeface="Calibri" pitchFamily="34" charset="-120"/>
               </a:rPr>
-              <a:t>Elegir el umbral por valor esperado: prob. × valor del cliente × efectividad de la oferta − costo</a:t>
+              <a:t>Elegir el umbral por valor esperado: prob. × valor del cliente × efectividad de la </a:t>
+            </a:r>
+            <a:r>
+              <a:rPr lang="en-US" sz="1350" dirty="0" err="1">
+                <a:solidFill>
+                  <a:srgbClr val="2B3147"/>
+                </a:solidFill>
+                <a:latin typeface="Calibri" pitchFamily="34" charset="0"/>
+                <a:ea typeface="Calibri" pitchFamily="34" charset="-122"/>
+                <a:cs typeface="Calibri" pitchFamily="34" charset="-120"/>
+              </a:rPr>
+              <a:t>oferta-costo</a:t>
             </a:r>
             <a:endParaRPr lang="en-US" sz="1350" dirty="0"/>
           </a:p>
@@ -6349,7 +6262,7 @@
         </p:nvSpPr>
         <p:spPr>
           <a:xfrm>
-            <a:off x="2816352" y="2911304"/>
+            <a:off x="2816352" y="2789646"/>
             <a:ext cx="1554480" cy="786384"/>
           </a:xfrm>
           <a:prstGeom prst="rect">
@@ -6562,7 +6475,7 @@
         </p:nvSpPr>
         <p:spPr>
           <a:xfrm>
-            <a:off x="5010912" y="2911304"/>
+            <a:off x="5010912" y="2812415"/>
             <a:ext cx="1554480" cy="786384"/>
           </a:xfrm>
           <a:prstGeom prst="rect">
@@ -6736,7 +6649,7 @@
         </p:nvSpPr>
         <p:spPr>
           <a:xfrm>
-            <a:off x="7205472" y="2344376"/>
+            <a:off x="7205472" y="2271224"/>
             <a:ext cx="1554480" cy="566928"/>
           </a:xfrm>
           <a:prstGeom prst="rect">
@@ -6775,7 +6688,7 @@
         </p:nvSpPr>
         <p:spPr>
           <a:xfrm>
-            <a:off x="7205472" y="2911304"/>
+            <a:off x="7205472" y="2812415"/>
             <a:ext cx="1554480" cy="786384"/>
           </a:xfrm>
           <a:prstGeom prst="rect">
@@ -7226,8 +7139,8 @@
         </p:nvSpPr>
         <p:spPr>
           <a:xfrm>
-            <a:off x="5577840" y="1280160"/>
-            <a:ext cx="3108960" cy="2280550"/>
+            <a:off x="5577840" y="1538129"/>
+            <a:ext cx="3108960" cy="1156625"/>
           </a:xfrm>
           <a:prstGeom prst="roundRect">
             <a:avLst>
@@ -7256,45 +7169,6 @@
       </p:sp>
       <p:sp>
         <p:nvSpPr>
-          <p:cNvPr id="12" name="Text 10"/>
-          <p:cNvSpPr/>
-          <p:nvPr/>
-        </p:nvSpPr>
-        <p:spPr>
-          <a:xfrm>
-            <a:off x="5806440" y="1417320"/>
-            <a:ext cx="2651760" cy="310896"/>
-          </a:xfrm>
-          <a:prstGeom prst="rect">
-            <a:avLst/>
-          </a:prstGeom>
-          <a:noFill/>
-          <a:ln/>
-        </p:spPr>
-        <p:txBody>
-          <a:bodyPr wrap="square" lIns="0" tIns="0" rIns="0" bIns="0" rtlCol="0" anchor="ctr"/>
-          <a:lstStyle/>
-          <a:p>
-            <a:pPr marL="0" indent="0">
-              <a:buNone/>
-            </a:pPr>
-            <a:r>
-              <a:rPr lang="en-US" sz="1500" b="1" dirty="0">
-                <a:solidFill>
-                  <a:srgbClr val="1E2761"/>
-                </a:solidFill>
-                <a:latin typeface="Calibri" pitchFamily="34" charset="0"/>
-                <a:ea typeface="Calibri" pitchFamily="34" charset="-122"/>
-                <a:cs typeface="Calibri" pitchFamily="34" charset="-120"/>
-              </a:rPr>
-              <a:t>Limitaciones</a:t>
-            </a:r>
-            <a:endParaRPr lang="en-US" sz="1500" dirty="0"/>
-          </a:p>
-        </p:txBody>
-      </p:sp>
-      <p:sp>
-        <p:nvSpPr>
           <p:cNvPr id="13" name="Text 11"/>
           <p:cNvSpPr/>
           <p:nvPr/>
@@ -7314,13 +7188,20 @@
           <a:bodyPr wrap="square" lIns="0" tIns="0" rIns="0" bIns="0" rtlCol="0" anchor="t"/>
           <a:lstStyle/>
           <a:p>
-            <a:pPr marL="342900" indent="-342900">
-              <a:spcAft>
-                <a:spcPts val="800"/>
-              </a:spcAft>
+            <a:pPr>
               <a:buSzPct val="100000"/>
-              <a:buChar char="•"/>
-            </a:pPr>
+            </a:pPr>
+            <a:r>
+              <a:rPr lang="en-US" sz="1300" dirty="0" err="1">
+                <a:solidFill>
+                  <a:srgbClr val="2B3147"/>
+                </a:solidFill>
+                <a:latin typeface="Calibri" pitchFamily="34" charset="0"/>
+                <a:ea typeface="Calibri" pitchFamily="34" charset="-122"/>
+                <a:cs typeface="Calibri" pitchFamily="34" charset="-120"/>
+              </a:rPr>
+              <a:t>Única</a:t>
+            </a:r>
             <a:r>
               <a:rPr lang="en-US" sz="1300" dirty="0">
                 <a:solidFill>
@@ -7330,46 +7211,7 @@
                 <a:ea typeface="Calibri" pitchFamily="34" charset="-122"/>
                 <a:cs typeface="Calibri" pitchFamily="34" charset="-120"/>
               </a:rPr>
-              <a:t>Foto de un solo mes: sin historia ni tendencias</a:t>
-            </a:r>
-            <a:endParaRPr lang="en-US" sz="1300" dirty="0"/>
-          </a:p>
-          <a:p>
-            <a:pPr marL="342900" indent="-342900">
-              <a:spcAft>
-                <a:spcPts val="800"/>
-              </a:spcAft>
-              <a:buSzPct val="100000"/>
-              <a:buChar char="•"/>
-            </a:pPr>
-            <a:r>
-              <a:rPr lang="en-US" sz="1300" dirty="0">
-                <a:solidFill>
-                  <a:srgbClr val="2B3147"/>
-                </a:solidFill>
-                <a:latin typeface="Calibri" pitchFamily="34" charset="0"/>
-                <a:ea typeface="Calibri" pitchFamily="34" charset="-122"/>
-                <a:cs typeface="Calibri" pitchFamily="34" charset="-120"/>
-              </a:rPr>
-              <a:t>Sin datos de uso, reclamos ni satisfacción</a:t>
-            </a:r>
-            <a:endParaRPr lang="en-US" sz="1300" dirty="0"/>
-          </a:p>
-          <a:p>
-            <a:pPr marL="342900" indent="-342900">
-              <a:buSzPct val="100000"/>
-              <a:buChar char="•"/>
-            </a:pPr>
-            <a:r>
-              <a:rPr lang="en-US" sz="1300" dirty="0">
-                <a:solidFill>
-                  <a:srgbClr val="2B3147"/>
-                </a:solidFill>
-                <a:latin typeface="Calibri" pitchFamily="34" charset="0"/>
-                <a:ea typeface="Calibri" pitchFamily="34" charset="-122"/>
-                <a:cs typeface="Calibri" pitchFamily="34" charset="-120"/>
-              </a:rPr>
-              <a:t>Única limpieza: TotalCharges vacío en 11 clientes nuevos (tenure = 0) → se imputa 0</a:t>
+              <a:t> limpieza: TotalCharges vacío en 11 clientes nuevos (tenure = 0) → se imputa 0</a:t>
             </a:r>
             <a:endParaRPr lang="en-US" sz="1300" dirty="0"/>
           </a:p>
@@ -9339,7 +9181,7 @@
                 <a:ea typeface="Calibri" pitchFamily="34" charset="-122"/>
                 <a:cs typeface="Calibri" pitchFamily="34" charset="-120"/>
               </a:rPr>
-              <a:t>5 · SELECCIÓN DE MODELOS</a:t>
+              <a:t>5 · Feature Engineering</a:t>
             </a:r>
             <a:endParaRPr lang="en-US" sz="1200" dirty="0"/>
           </a:p>
@@ -10250,7 +10092,7 @@
                 <a:ea typeface="Calibri" pitchFamily="34" charset="-122"/>
                 <a:cs typeface="Calibri" pitchFamily="34" charset="-120"/>
               </a:rPr>
-              <a:t>Baseline: regresión logística sin tuning — una vara sorprendentemente alta</a:t>
+              <a:t>Baseline: regresión logística sin tuning </a:t>
             </a:r>
             <a:endParaRPr lang="en-US" sz="2500" dirty="0"/>
           </a:p>

</xml_diff>